<commit_message>
Repartition presentation: 2 slides par personne dans l ordre.
</commit_message>
<xml_diff>
--- a/presentation/PRESENTATION-G4-Les_Hadoop_Riders.pptx
+++ b/presentation/PRESENTATION-G4-Les_Hadoop_Riders.pptx
@@ -653,7 +653,7 @@
           <a:lstStyle/>
           <a:p>
             <a:r>
-              <a:t>Un problème = une cause = une solution. Puis passer à Wren pour conclure.</a:t>
+              <a:t>Un problème = une cause = une solution. Enchaîner directement sur la conclusion.</a:t>
             </a:r>
           </a:p>
         </p:txBody>
@@ -793,7 +793,7 @@
           <a:lstStyle/>
           <a:p>
             <a:r>
-              <a:t>Annoncer l’ordre. Préciser que Wren (dernière) fait la conclusion.</a:t>
+              <a:t>Annoncer : chacun a 2 slides, dans l’ordre. Wren (dernière) conclut.</a:t>
             </a:r>
           </a:p>
         </p:txBody>
@@ -1213,7 +1213,7 @@
           <a:lstStyle/>
           <a:p>
             <a:r>
-              <a:t>Suivre les 5 étapes. Expliquer Trash et setrep. Reviendra pour la conclusion.</a:t>
+              <a:t>Suivre les 5 étapes. Expliquer Trash et setrep.</a:t>
             </a:r>
           </a:p>
         </p:txBody>
@@ -5394,7 +5394,7 @@
                 </a:solidFill>
                 <a:latin typeface="Calibri"/>
               </a:rPr>
-              <a:t>Présenté par : Joel Kazoni Tugirimana</a:t>
+              <a:t>Présenté par : Frank A Simo Ngounou</a:t>
             </a:r>
           </a:p>
         </p:txBody>
@@ -6209,7 +6209,7 @@
                 </a:solidFill>
                 <a:latin typeface="Calibri"/>
               </a:rPr>
-              <a:t>Présenté par : Kassoum Dene</a:t>
+              <a:t>Présenté par : Wren Surprenant-Nicolson</a:t>
             </a:r>
           </a:p>
         </p:txBody>
@@ -7467,7 +7467,7 @@
                 </a:solidFill>
                 <a:latin typeface="Calibri"/>
               </a:rPr>
-              <a:t>Plan — qui présente quoi</a:t>
+              <a:t>Plan — 2 slides par personne, dans l’ordre</a:t>
             </a:r>
           </a:p>
         </p:txBody>
@@ -7506,7 +7506,7 @@
                 </a:solidFill>
                 <a:latin typeface="Calibri"/>
               </a:rPr>
-              <a:t>Environ 8–10 minutes. Chaque slide indique le présentateur en bas.</a:t>
+              <a:t>8–10 min · ordre du groupe · 2 slides chacun · Wren termine avec la conclusion</a:t>
             </a:r>
           </a:p>
         </p:txBody>
@@ -7519,8 +7519,8 @@
         </p:nvSpPr>
         <p:spPr>
           <a:xfrm>
-            <a:off x="411480" y="1600200"/>
-            <a:ext cx="3657600" cy="1280160"/>
+            <a:off x="411480" y="1691640"/>
+            <a:ext cx="3657600" cy="1783080"/>
           </a:xfrm>
           <a:prstGeom prst="roundRect">
             <a:avLst>
@@ -7566,8 +7566,8 @@
         </p:nvSpPr>
         <p:spPr>
           <a:xfrm>
-            <a:off x="594360" y="1783080"/>
-            <a:ext cx="3291840" cy="1005840"/>
+            <a:off x="594360" y="1920240"/>
+            <a:ext cx="3291840" cy="1417320"/>
           </a:xfrm>
           <a:prstGeom prst="rect">
             <a:avLst/>
@@ -7582,33 +7582,33 @@
           <a:p>
             <a:pPr algn="l">
               <a:spcAft>
-                <a:spcPts val="400"/>
-              </a:spcAft>
-            </a:pPr>
-            <a:r>
-              <a:rPr sz="1200" b="1">
+                <a:spcPts val="600"/>
+              </a:spcAft>
+            </a:pPr>
+            <a:r>
+              <a:rPr sz="1300" b="1">
                 <a:solidFill>
                   <a:srgbClr val="0F5C4C"/>
                 </a:solidFill>
                 <a:latin typeface="Calibri"/>
               </a:rPr>
-              <a:t>Slide 3</a:t>
-            </a:r>
-          </a:p>
-          <a:p>
-            <a:pPr algn="l">
-              <a:spcAft>
-                <a:spcPts val="400"/>
-              </a:spcAft>
-            </a:pPr>
-            <a:r>
-              <a:rPr sz="1600" b="1">
+              <a:t>Slides 1–2</a:t>
+            </a:r>
+          </a:p>
+          <a:p>
+            <a:pPr algn="l">
+              <a:spcAft>
+                <a:spcPts val="800"/>
+              </a:spcAft>
+            </a:pPr>
+            <a:r>
+              <a:rPr sz="1500" b="1">
                 <a:solidFill>
                   <a:srgbClr val="1E293B"/>
                 </a:solidFill>
                 <a:latin typeface="Calibri"/>
               </a:rPr>
-              <a:t>3V e-commerce</a:t>
+              <a:t>Titre + plan</a:t>
             </a:r>
           </a:p>
           <a:p>
@@ -7624,7 +7624,7 @@
                 </a:solidFill>
                 <a:latin typeface="Calibri"/>
               </a:rPr>
-              <a:t>Kassoum</a:t>
+              <a:t>Komla Petro Asinyo</a:t>
             </a:r>
           </a:p>
         </p:txBody>
@@ -7637,8 +7637,8 @@
         </p:nvSpPr>
         <p:spPr>
           <a:xfrm>
-            <a:off x="4251960" y="1600200"/>
-            <a:ext cx="3657600" cy="1280160"/>
+            <a:off x="4251960" y="1691640"/>
+            <a:ext cx="3657600" cy="1783080"/>
           </a:xfrm>
           <a:prstGeom prst="roundRect">
             <a:avLst>
@@ -7684,8 +7684,8 @@
         </p:nvSpPr>
         <p:spPr>
           <a:xfrm>
-            <a:off x="4434840" y="1783080"/>
-            <a:ext cx="3291840" cy="1005840"/>
+            <a:off x="4434840" y="1920240"/>
+            <a:ext cx="3291840" cy="1417320"/>
           </a:xfrm>
           <a:prstGeom prst="rect">
             <a:avLst/>
@@ -7700,33 +7700,33 @@
           <a:p>
             <a:pPr algn="l">
               <a:spcAft>
-                <a:spcPts val="400"/>
-              </a:spcAft>
-            </a:pPr>
-            <a:r>
-              <a:rPr sz="1200" b="1">
+                <a:spcPts val="600"/>
+              </a:spcAft>
+            </a:pPr>
+            <a:r>
+              <a:rPr sz="1300" b="1">
                 <a:solidFill>
                   <a:srgbClr val="0F5C4C"/>
                 </a:solidFill>
                 <a:latin typeface="Calibri"/>
               </a:rPr>
-              <a:t>Slide 4</a:t>
-            </a:r>
-          </a:p>
-          <a:p>
-            <a:pPr algn="l">
-              <a:spcAft>
-                <a:spcPts val="400"/>
-              </a:spcAft>
-            </a:pPr>
-            <a:r>
-              <a:rPr sz="1600" b="1">
+              <a:t>Slides 3–4</a:t>
+            </a:r>
+          </a:p>
+          <a:p>
+            <a:pPr algn="l">
+              <a:spcAft>
+                <a:spcPts val="800"/>
+              </a:spcAft>
+            </a:pPr>
+            <a:r>
+              <a:rPr sz="1500" b="1">
                 <a:solidFill>
                   <a:srgbClr val="1E293B"/>
                 </a:solidFill>
                 <a:latin typeface="Calibri"/>
               </a:rPr>
-              <a:t>HDFS vs local</a:t>
+              <a:t>3V + HDFS vs local</a:t>
             </a:r>
           </a:p>
           <a:p>
@@ -7742,7 +7742,7 @@
                 </a:solidFill>
                 <a:latin typeface="Calibri"/>
               </a:rPr>
-              <a:t>Joel</a:t>
+              <a:t>Kassoum Dene</a:t>
             </a:r>
           </a:p>
         </p:txBody>
@@ -7755,8 +7755,8 @@
         </p:nvSpPr>
         <p:spPr>
           <a:xfrm>
-            <a:off x="8092440" y="1600200"/>
-            <a:ext cx="3657600" cy="1280160"/>
+            <a:off x="8092440" y="1691640"/>
+            <a:ext cx="3657600" cy="1783080"/>
           </a:xfrm>
           <a:prstGeom prst="roundRect">
             <a:avLst>
@@ -7802,8 +7802,8 @@
         </p:nvSpPr>
         <p:spPr>
           <a:xfrm>
-            <a:off x="8275319" y="1783080"/>
-            <a:ext cx="3291840" cy="1005840"/>
+            <a:off x="8275319" y="1920240"/>
+            <a:ext cx="3291840" cy="1417320"/>
           </a:xfrm>
           <a:prstGeom prst="rect">
             <a:avLst/>
@@ -7818,33 +7818,33 @@
           <a:p>
             <a:pPr algn="l">
               <a:spcAft>
-                <a:spcPts val="400"/>
-              </a:spcAft>
-            </a:pPr>
-            <a:r>
-              <a:rPr sz="1200" b="1">
+                <a:spcPts val="600"/>
+              </a:spcAft>
+            </a:pPr>
+            <a:r>
+              <a:rPr sz="1300" b="1">
                 <a:solidFill>
                   <a:srgbClr val="0F5C4C"/>
                 </a:solidFill>
                 <a:latin typeface="Calibri"/>
               </a:rPr>
-              <a:t>Slide 5</a:t>
-            </a:r>
-          </a:p>
-          <a:p>
-            <a:pPr algn="l">
-              <a:spcAft>
-                <a:spcPts val="400"/>
-              </a:spcAft>
-            </a:pPr>
-            <a:r>
-              <a:rPr sz="1600" b="1">
+              <a:t>Slides 5–6</a:t>
+            </a:r>
+          </a:p>
+          <a:p>
+            <a:pPr algn="l">
+              <a:spcAft>
+                <a:spcPts val="800"/>
+              </a:spcAft>
+            </a:pPr>
+            <a:r>
+              <a:rPr sz="1500" b="1">
                 <a:solidFill>
                   <a:srgbClr val="1E293B"/>
                 </a:solidFill>
                 <a:latin typeface="Calibri"/>
               </a:rPr>
-              <a:t>YARN RM / NM</a:t>
+              <a:t>YARN + architecture</a:t>
             </a:r>
           </a:p>
           <a:p>
@@ -7860,7 +7860,7 @@
                 </a:solidFill>
                 <a:latin typeface="Calibri"/>
               </a:rPr>
-              <a:t>Forbes</a:t>
+              <a:t>Joel Kazoni Tugirimana</a:t>
             </a:r>
           </a:p>
         </p:txBody>
@@ -7873,8 +7873,8 @@
         </p:nvSpPr>
         <p:spPr>
           <a:xfrm>
-            <a:off x="411480" y="3017520"/>
-            <a:ext cx="3657600" cy="1280160"/>
+            <a:off x="411480" y="3703320"/>
+            <a:ext cx="3657600" cy="1783080"/>
           </a:xfrm>
           <a:prstGeom prst="roundRect">
             <a:avLst>
@@ -7920,8 +7920,8 @@
         </p:nvSpPr>
         <p:spPr>
           <a:xfrm>
-            <a:off x="594360" y="3200400"/>
-            <a:ext cx="3291840" cy="1005840"/>
+            <a:off x="594360" y="3931920"/>
+            <a:ext cx="3291840" cy="1417320"/>
           </a:xfrm>
           <a:prstGeom prst="rect">
             <a:avLst/>
@@ -7936,33 +7936,33 @@
           <a:p>
             <a:pPr algn="l">
               <a:spcAft>
-                <a:spcPts val="400"/>
-              </a:spcAft>
-            </a:pPr>
-            <a:r>
-              <a:rPr sz="1200" b="1">
+                <a:spcPts val="600"/>
+              </a:spcAft>
+            </a:pPr>
+            <a:r>
+              <a:rPr sz="1300" b="1">
                 <a:solidFill>
                   <a:srgbClr val="0F5C4C"/>
                 </a:solidFill>
                 <a:latin typeface="Calibri"/>
               </a:rPr>
-              <a:t>Slide 6–7</a:t>
-            </a:r>
-          </a:p>
-          <a:p>
-            <a:pPr algn="l">
-              <a:spcAft>
-                <a:spcPts val="400"/>
-              </a:spcAft>
-            </a:pPr>
-            <a:r>
-              <a:rPr sz="1600" b="1">
+              <a:t>Slides 7–8</a:t>
+            </a:r>
+          </a:p>
+          <a:p>
+            <a:pPr algn="l">
+              <a:spcAft>
+                <a:spcPts val="800"/>
+              </a:spcAft>
+            </a:pPr>
+            <a:r>
+              <a:rPr sz="1500" b="1">
                 <a:solidFill>
                   <a:srgbClr val="1E293B"/>
                 </a:solidFill>
                 <a:latin typeface="Calibri"/>
               </a:rPr>
-              <a:t>Archi + Hub</a:t>
+              <a:t>Déploiement Hub + HDFS</a:t>
             </a:r>
           </a:p>
           <a:p>
@@ -7978,7 +7978,7 @@
                 </a:solidFill>
                 <a:latin typeface="Calibri"/>
               </a:rPr>
-              <a:t>Frank</a:t>
+              <a:t>Forbes Magène</a:t>
             </a:r>
           </a:p>
         </p:txBody>
@@ -7991,8 +7991,8 @@
         </p:nvSpPr>
         <p:spPr>
           <a:xfrm>
-            <a:off x="4251960" y="3017520"/>
-            <a:ext cx="3657600" cy="1280160"/>
+            <a:off x="4251960" y="3703320"/>
+            <a:ext cx="3657600" cy="1783080"/>
           </a:xfrm>
           <a:prstGeom prst="roundRect">
             <a:avLst>
@@ -8038,8 +8038,8 @@
         </p:nvSpPr>
         <p:spPr>
           <a:xfrm>
-            <a:off x="4434840" y="3200400"/>
-            <a:ext cx="3291840" cy="1005840"/>
+            <a:off x="4434840" y="3931920"/>
+            <a:ext cx="3291840" cy="1417320"/>
           </a:xfrm>
           <a:prstGeom prst="rect">
             <a:avLst/>
@@ -8054,33 +8054,33 @@
           <a:p>
             <a:pPr algn="l">
               <a:spcAft>
-                <a:spcPts val="400"/>
-              </a:spcAft>
-            </a:pPr>
-            <a:r>
-              <a:rPr sz="1200" b="1">
+                <a:spcPts val="600"/>
+              </a:spcAft>
+            </a:pPr>
+            <a:r>
+              <a:rPr sz="1300" b="1">
                 <a:solidFill>
                   <a:srgbClr val="0F5C4C"/>
                 </a:solidFill>
                 <a:latin typeface="Calibri"/>
               </a:rPr>
-              <a:t>Slide 8</a:t>
-            </a:r>
-          </a:p>
-          <a:p>
-            <a:pPr algn="l">
-              <a:spcAft>
-                <a:spcPts val="400"/>
-              </a:spcAft>
-            </a:pPr>
-            <a:r>
-              <a:rPr sz="1600" b="1">
+              <a:t>Slides 9–10</a:t>
+            </a:r>
+          </a:p>
+          <a:p>
+            <a:pPr algn="l">
+              <a:spcAft>
+                <a:spcPts val="800"/>
+              </a:spcAft>
+            </a:pPr>
+            <a:r>
+              <a:rPr sz="1500" b="1">
                 <a:solidFill>
                   <a:srgbClr val="1E293B"/>
                 </a:solidFill>
                 <a:latin typeface="Calibri"/>
               </a:rPr>
-              <a:t>HDFS pratique</a:t>
+              <a:t>Job π + monitoring</a:t>
             </a:r>
           </a:p>
           <a:p>
@@ -8096,7 +8096,7 @@
                 </a:solidFill>
                 <a:latin typeface="Calibri"/>
               </a:rPr>
-              <a:t>Wren</a:t>
+              <a:t>Frank A Simo Ngounou</a:t>
             </a:r>
           </a:p>
         </p:txBody>
@@ -8109,8 +8109,8 @@
         </p:nvSpPr>
         <p:spPr>
           <a:xfrm>
-            <a:off x="8092440" y="3017520"/>
-            <a:ext cx="3657600" cy="1280160"/>
+            <a:off x="8092440" y="3703320"/>
+            <a:ext cx="3657600" cy="1783080"/>
           </a:xfrm>
           <a:prstGeom prst="roundRect">
             <a:avLst>
@@ -8156,8 +8156,8 @@
         </p:nvSpPr>
         <p:spPr>
           <a:xfrm>
-            <a:off x="8275319" y="3200400"/>
-            <a:ext cx="3291840" cy="1005840"/>
+            <a:off x="8275319" y="3931920"/>
+            <a:ext cx="3291840" cy="1417320"/>
           </a:xfrm>
           <a:prstGeom prst="rect">
             <a:avLst/>
@@ -8172,33 +8172,33 @@
           <a:p>
             <a:pPr algn="l">
               <a:spcAft>
-                <a:spcPts val="400"/>
-              </a:spcAft>
-            </a:pPr>
-            <a:r>
-              <a:rPr sz="1200" b="1">
+                <a:spcPts val="600"/>
+              </a:spcAft>
+            </a:pPr>
+            <a:r>
+              <a:rPr sz="1300" b="1">
                 <a:solidFill>
                   <a:srgbClr val="0F5C4C"/>
                 </a:solidFill>
                 <a:latin typeface="Calibri"/>
               </a:rPr>
-              <a:t>Slide 9</a:t>
-            </a:r>
-          </a:p>
-          <a:p>
-            <a:pPr algn="l">
-              <a:spcAft>
-                <a:spcPts val="400"/>
-              </a:spcAft>
-            </a:pPr>
-            <a:r>
-              <a:rPr sz="1600" b="1">
+              <a:t>Slides 11–12</a:t>
+            </a:r>
+          </a:p>
+          <a:p>
+            <a:pPr algn="l">
+              <a:spcAft>
+                <a:spcPts val="800"/>
+              </a:spcAft>
+            </a:pPr>
+            <a:r>
+              <a:rPr sz="1500" b="1">
                 <a:solidFill>
                   <a:srgbClr val="1E293B"/>
                 </a:solidFill>
                 <a:latin typeface="Calibri"/>
               </a:rPr>
-              <a:t>Job π</a:t>
+              <a:t>Problèmes + conclusion</a:t>
             </a:r>
           </a:p>
           <a:p>
@@ -8214,368 +8214,14 @@
                 </a:solidFill>
                 <a:latin typeface="Calibri"/>
               </a:rPr>
-              <a:t>Forbes</a:t>
-            </a:r>
-          </a:p>
-        </p:txBody>
-      </p:sp>
-      <p:sp>
-        <p:nvSpPr>
-          <p:cNvPr id="19" name="Rounded Rectangle 18"/>
-          <p:cNvSpPr/>
-          <p:nvPr/>
-        </p:nvSpPr>
-        <p:spPr>
-          <a:xfrm>
-            <a:off x="411480" y="4434840"/>
-            <a:ext cx="3657600" cy="1280160"/>
-          </a:xfrm>
-          <a:prstGeom prst="roundRect">
-            <a:avLst>
-              <a:gd name="adj" fmla="val 8000"/>
-            </a:avLst>
-          </a:prstGeom>
-          <a:solidFill>
-            <a:srgbClr val="FFFFFF"/>
-          </a:solidFill>
-          <a:ln w="15875">
-            <a:solidFill>
-              <a:srgbClr val="147A66"/>
-            </a:solidFill>
-          </a:ln>
-        </p:spPr>
-        <p:style>
-          <a:lnRef idx="1">
-            <a:schemeClr val="accent1"/>
-          </a:lnRef>
-          <a:fillRef idx="3">
-            <a:schemeClr val="accent1"/>
-          </a:fillRef>
-          <a:effectRef idx="2">
-            <a:schemeClr val="accent1"/>
-          </a:effectRef>
-          <a:fontRef idx="minor">
-            <a:schemeClr val="lt1"/>
-          </a:fontRef>
-        </p:style>
-        <p:txBody>
-          <a:bodyPr rtlCol="0" anchor="ctr"/>
-          <a:lstStyle/>
-          <a:p>
-            <a:pPr algn="ctr"/>
-          </a:p>
-        </p:txBody>
-      </p:sp>
-      <p:sp>
-        <p:nvSpPr>
-          <p:cNvPr id="20" name="TextBox 19"/>
-          <p:cNvSpPr txBox="1"/>
-          <p:nvPr/>
-        </p:nvSpPr>
-        <p:spPr>
-          <a:xfrm>
-            <a:off x="594360" y="4617720"/>
-            <a:ext cx="3291840" cy="1005840"/>
-          </a:xfrm>
-          <a:prstGeom prst="rect">
-            <a:avLst/>
-          </a:prstGeom>
-          <a:noFill/>
-        </p:spPr>
-        <p:txBody>
-          <a:bodyPr wrap="square">
-            <a:spAutoFit/>
-          </a:bodyPr>
-          <a:lstStyle/>
-          <a:p>
-            <a:pPr algn="l">
-              <a:spcAft>
-                <a:spcPts val="400"/>
-              </a:spcAft>
-            </a:pPr>
-            <a:r>
-              <a:rPr sz="1200" b="1">
-                <a:solidFill>
-                  <a:srgbClr val="0F5C4C"/>
-                </a:solidFill>
-                <a:latin typeface="Calibri"/>
-              </a:rPr>
-              <a:t>Slide 10</a:t>
-            </a:r>
-          </a:p>
-          <a:p>
-            <a:pPr algn="l">
-              <a:spcAft>
-                <a:spcPts val="400"/>
-              </a:spcAft>
-            </a:pPr>
-            <a:r>
-              <a:rPr sz="1600" b="1">
-                <a:solidFill>
-                  <a:srgbClr val="1E293B"/>
-                </a:solidFill>
-                <a:latin typeface="Calibri"/>
-              </a:rPr>
-              <a:t>Monitoring</a:t>
-            </a:r>
-          </a:p>
-          <a:p>
-            <a:pPr algn="l">
-              <a:spcAft>
-                <a:spcPts val="500"/>
-              </a:spcAft>
-            </a:pPr>
-            <a:r>
-              <a:rPr sz="1300" b="0">
-                <a:solidFill>
-                  <a:srgbClr val="64748B"/>
-                </a:solidFill>
-                <a:latin typeface="Calibri"/>
-              </a:rPr>
-              <a:t>Joel</a:t>
-            </a:r>
-          </a:p>
-        </p:txBody>
-      </p:sp>
-      <p:sp>
-        <p:nvSpPr>
-          <p:cNvPr id="21" name="Rounded Rectangle 20"/>
-          <p:cNvSpPr/>
-          <p:nvPr/>
-        </p:nvSpPr>
-        <p:spPr>
-          <a:xfrm>
-            <a:off x="4251960" y="4434840"/>
-            <a:ext cx="3657600" cy="1280160"/>
-          </a:xfrm>
-          <a:prstGeom prst="roundRect">
-            <a:avLst>
-              <a:gd name="adj" fmla="val 8000"/>
-            </a:avLst>
-          </a:prstGeom>
-          <a:solidFill>
-            <a:srgbClr val="FFFFFF"/>
-          </a:solidFill>
-          <a:ln w="15875">
-            <a:solidFill>
-              <a:srgbClr val="147A66"/>
-            </a:solidFill>
-          </a:ln>
-        </p:spPr>
-        <p:style>
-          <a:lnRef idx="1">
-            <a:schemeClr val="accent1"/>
-          </a:lnRef>
-          <a:fillRef idx="3">
-            <a:schemeClr val="accent1"/>
-          </a:fillRef>
-          <a:effectRef idx="2">
-            <a:schemeClr val="accent1"/>
-          </a:effectRef>
-          <a:fontRef idx="minor">
-            <a:schemeClr val="lt1"/>
-          </a:fontRef>
-        </p:style>
-        <p:txBody>
-          <a:bodyPr rtlCol="0" anchor="ctr"/>
-          <a:lstStyle/>
-          <a:p>
-            <a:pPr algn="ctr"/>
-          </a:p>
-        </p:txBody>
-      </p:sp>
-      <p:sp>
-        <p:nvSpPr>
-          <p:cNvPr id="22" name="TextBox 21"/>
-          <p:cNvSpPr txBox="1"/>
-          <p:nvPr/>
-        </p:nvSpPr>
-        <p:spPr>
-          <a:xfrm>
-            <a:off x="4434840" y="4617720"/>
-            <a:ext cx="3291840" cy="1005840"/>
-          </a:xfrm>
-          <a:prstGeom prst="rect">
-            <a:avLst/>
-          </a:prstGeom>
-          <a:noFill/>
-        </p:spPr>
-        <p:txBody>
-          <a:bodyPr wrap="square">
-            <a:spAutoFit/>
-          </a:bodyPr>
-          <a:lstStyle/>
-          <a:p>
-            <a:pPr algn="l">
-              <a:spcAft>
-                <a:spcPts val="400"/>
-              </a:spcAft>
-            </a:pPr>
-            <a:r>
-              <a:rPr sz="1200" b="1">
-                <a:solidFill>
-                  <a:srgbClr val="0F5C4C"/>
-                </a:solidFill>
-                <a:latin typeface="Calibri"/>
-              </a:rPr>
-              <a:t>Slide 11</a:t>
-            </a:r>
-          </a:p>
-          <a:p>
-            <a:pPr algn="l">
-              <a:spcAft>
-                <a:spcPts val="400"/>
-              </a:spcAft>
-            </a:pPr>
-            <a:r>
-              <a:rPr sz="1600" b="1">
-                <a:solidFill>
-                  <a:srgbClr val="1E293B"/>
-                </a:solidFill>
-                <a:latin typeface="Calibri"/>
-              </a:rPr>
-              <a:t>Problèmes</a:t>
-            </a:r>
-          </a:p>
-          <a:p>
-            <a:pPr algn="l">
-              <a:spcAft>
-                <a:spcPts val="500"/>
-              </a:spcAft>
-            </a:pPr>
-            <a:r>
-              <a:rPr sz="1300" b="0">
-                <a:solidFill>
-                  <a:srgbClr val="64748B"/>
-                </a:solidFill>
-                <a:latin typeface="Calibri"/>
-              </a:rPr>
-              <a:t>Kassoum</a:t>
-            </a:r>
-          </a:p>
-        </p:txBody>
-      </p:sp>
-      <p:sp>
-        <p:nvSpPr>
-          <p:cNvPr id="23" name="Rounded Rectangle 22"/>
-          <p:cNvSpPr/>
-          <p:nvPr/>
-        </p:nvSpPr>
-        <p:spPr>
-          <a:xfrm>
-            <a:off x="8092440" y="4434840"/>
-            <a:ext cx="3657600" cy="1280160"/>
-          </a:xfrm>
-          <a:prstGeom prst="roundRect">
-            <a:avLst>
-              <a:gd name="adj" fmla="val 8000"/>
-            </a:avLst>
-          </a:prstGeom>
-          <a:solidFill>
-            <a:srgbClr val="FFFFFF"/>
-          </a:solidFill>
-          <a:ln w="15875">
-            <a:solidFill>
-              <a:srgbClr val="147A66"/>
-            </a:solidFill>
-          </a:ln>
-        </p:spPr>
-        <p:style>
-          <a:lnRef idx="1">
-            <a:schemeClr val="accent1"/>
-          </a:lnRef>
-          <a:fillRef idx="3">
-            <a:schemeClr val="accent1"/>
-          </a:fillRef>
-          <a:effectRef idx="2">
-            <a:schemeClr val="accent1"/>
-          </a:effectRef>
-          <a:fontRef idx="minor">
-            <a:schemeClr val="lt1"/>
-          </a:fontRef>
-        </p:style>
-        <p:txBody>
-          <a:bodyPr rtlCol="0" anchor="ctr"/>
-          <a:lstStyle/>
-          <a:p>
-            <a:pPr algn="ctr"/>
-          </a:p>
-        </p:txBody>
-      </p:sp>
-      <p:sp>
-        <p:nvSpPr>
-          <p:cNvPr id="24" name="TextBox 23"/>
-          <p:cNvSpPr txBox="1"/>
-          <p:nvPr/>
-        </p:nvSpPr>
-        <p:spPr>
-          <a:xfrm>
-            <a:off x="8275319" y="4617720"/>
-            <a:ext cx="3291840" cy="1005840"/>
-          </a:xfrm>
-          <a:prstGeom prst="rect">
-            <a:avLst/>
-          </a:prstGeom>
-          <a:noFill/>
-        </p:spPr>
-        <p:txBody>
-          <a:bodyPr wrap="square">
-            <a:spAutoFit/>
-          </a:bodyPr>
-          <a:lstStyle/>
-          <a:p>
-            <a:pPr algn="l">
-              <a:spcAft>
-                <a:spcPts val="400"/>
-              </a:spcAft>
-            </a:pPr>
-            <a:r>
-              <a:rPr sz="1200" b="1">
-                <a:solidFill>
-                  <a:srgbClr val="0F5C4C"/>
-                </a:solidFill>
-                <a:latin typeface="Calibri"/>
-              </a:rPr>
-              <a:t>Slide 12</a:t>
-            </a:r>
-          </a:p>
-          <a:p>
-            <a:pPr algn="l">
-              <a:spcAft>
-                <a:spcPts val="400"/>
-              </a:spcAft>
-            </a:pPr>
-            <a:r>
-              <a:rPr sz="1600" b="1">
-                <a:solidFill>
-                  <a:srgbClr val="1E293B"/>
-                </a:solidFill>
-                <a:latin typeface="Calibri"/>
-              </a:rPr>
-              <a:t>Conclusion</a:t>
-            </a:r>
-          </a:p>
-          <a:p>
-            <a:pPr algn="l">
-              <a:spcAft>
-                <a:spcPts val="500"/>
-              </a:spcAft>
-            </a:pPr>
-            <a:r>
-              <a:rPr sz="1300" b="0">
-                <a:solidFill>
-                  <a:srgbClr val="64748B"/>
-                </a:solidFill>
-                <a:latin typeface="Calibri"/>
-              </a:rPr>
-              <a:t>Wren</a:t>
-            </a:r>
-          </a:p>
-        </p:txBody>
-      </p:sp>
-      <p:sp>
-        <p:nvSpPr>
-          <p:cNvPr id="25" name="Rectangle 24"/>
+              <a:t>Wren Surprenant-Nicolson</a:t>
+            </a:r>
+          </a:p>
+        </p:txBody>
+      </p:sp>
+      <p:sp>
+        <p:nvSpPr>
+          <p:cNvPr id="19" name="Rectangle 18"/>
           <p:cNvSpPr/>
           <p:nvPr/>
         </p:nvSpPr>
@@ -8618,7 +8264,7 @@
       </p:sp>
       <p:sp>
         <p:nvSpPr>
-          <p:cNvPr id="26" name="TextBox 25"/>
+          <p:cNvPr id="20" name="TextBox 19"/>
           <p:cNvSpPr txBox="1"/>
           <p:nvPr/>
         </p:nvSpPr>
@@ -8652,7 +8298,7 @@
       </p:sp>
       <p:sp>
         <p:nvSpPr>
-          <p:cNvPr id="27" name="TextBox 26"/>
+          <p:cNvPr id="21" name="TextBox 20"/>
           <p:cNvSpPr txBox="1"/>
           <p:nvPr/>
         </p:nvSpPr>
@@ -10858,7 +10504,7 @@
                 </a:solidFill>
                 <a:latin typeface="Calibri"/>
               </a:rPr>
-              <a:t>Présenté par : Joel Kazoni Tugirimana</a:t>
+              <a:t>Présenté par : Kassoum Dene</a:t>
             </a:r>
           </a:p>
         </p:txBody>
@@ -11769,7 +11415,7 @@
                 </a:solidFill>
                 <a:latin typeface="Calibri"/>
               </a:rPr>
-              <a:t>Présenté par : Forbes Magène</a:t>
+              <a:t>Présenté par : Joel Kazoni Tugirimana</a:t>
             </a:r>
           </a:p>
         </p:txBody>
@@ -12870,7 +12516,7 @@
                 </a:solidFill>
                 <a:latin typeface="Calibri"/>
               </a:rPr>
-              <a:t>Présenté par : Frank A Simo Ngounou</a:t>
+              <a:t>Présenté par : Joel Kazoni Tugirimana</a:t>
             </a:r>
           </a:p>
         </p:txBody>
@@ -13467,7 +13113,7 @@
                 </a:solidFill>
                 <a:latin typeface="Calibri"/>
               </a:rPr>
-              <a:t>Présenté par : Frank A Simo Ngounou</a:t>
+              <a:t>Présenté par : Forbes Magène</a:t>
             </a:r>
           </a:p>
         </p:txBody>
@@ -14061,7 +13707,7 @@
                 </a:solidFill>
                 <a:latin typeface="Calibri"/>
               </a:rPr>
-              <a:t>Présenté par : Wren Surprenant-Nicolson</a:t>
+              <a:t>Présenté par : Forbes Magène</a:t>
             </a:r>
           </a:p>
         </p:txBody>
@@ -14657,7 +14303,7 @@
                 </a:solidFill>
                 <a:latin typeface="Calibri"/>
               </a:rPr>
-              <a:t>Présenté par : Forbes Magène</a:t>
+              <a:t>Présenté par : Frank A Simo Ngounou</a:t>
             </a:r>
           </a:p>
         </p:txBody>

</xml_diff>